<commit_message>
:pencil: finalize lecture 2
</commit_message>
<xml_diff>
--- a/lessons/lesson02_baseline_model/theory/slides/Lecture2 - Building the First Predictive Model.pptx
+++ b/lessons/lesson02_baseline_model/theory/slides/Lecture2 - Building the First Predictive Model.pptx
@@ -12239,6 +12239,42 @@
           </a:solidFill>
           <a:ln/>
         </p:spPr>
+      </p:sp>
+      <p:sp>
+        <p:nvSpPr>
+          <p:cNvPr id="790" name="gene B label"/>
+          <p:cNvSpPr/>
+          <p:nvPr/>
+        </p:nvSpPr>
+        <p:spPr>
+          <a:xfrm rot="-5400000">
+            <a:off x="5967920" y="3794760"/>
+            <a:ext cx="1097280" cy="274320"/>
+          </a:xfrm>
+          <a:prstGeom prst="rect">
+            <a:avLst/>
+          </a:prstGeom>
+          <a:noFill/>
+          <a:ln/>
+        </p:spPr>
+        <p:txBody>
+          <a:bodyPr wrap="square" lIns="0" tIns="0" rIns="0" bIns="0" rtlCol="0" anchor="ctr"/>
+          <a:lstStyle/>
+          <a:p>
+            <a:pPr marL="0" indent="0" algn="ctr">
+              <a:buNone/>
+            </a:pPr>
+            <a:r>
+              <a:rPr lang="en-US" sz="1000" dirty="0">
+                <a:solidFill>
+                  <a:srgbClr val="5B6B70"/>
+                </a:solidFill>
+                <a:latin typeface="Calibri" pitchFamily="34" charset="0"/>
+              </a:rPr>
+              <a:t>↑ gene B</a:t>
+            </a:r>
+          </a:p>
+        </p:txBody>
       </p:sp>
       <p:sp>
         <p:nvSpPr>

</xml_diff>

<commit_message>
:pencil: Final edit lect 2
</commit_message>
<xml_diff>
--- a/lessons/lesson02_baseline_model/theory/slides/Lecture2 - Building the First Predictive Model.pptx
+++ b/lessons/lesson02_baseline_model/theory/slides/Lecture2 - Building the First Predictive Model.pptx
@@ -1948,7 +1948,7 @@
               </a:defRPr>
             </a:pPr>
             <a:r>
-              <a:rPr sz="1300" b="0" i="0" u="none" strike="noStrike">
+              <a:rPr lang="en-GB" sz="1300" b="0" i="0" u="none" strike="noStrike">
                 <a:solidFill>
                   <a:srgbClr val="12262B"/>
                 </a:solidFill>
@@ -2215,7 +2215,7 @@
               </a:defRPr>
             </a:pPr>
             <a:r>
-              <a:rPr sz="1100" b="0" i="0" u="none" strike="noStrike">
+              <a:rPr lang="en-GB" sz="1100" b="0" i="0" u="none" strike="noStrike">
                 <a:solidFill>
                   <a:srgbClr val="12262B"/>
                 </a:solidFill>
@@ -2531,7 +2531,7 @@
                   </a:defRPr>
                 </a:pPr>
                 <a:r>
-                  <a:rPr sz="900" b="0" i="0" u="none" strike="noStrike">
+                  <a:rPr lang="en-GB" sz="900" b="0" i="0" u="none" strike="noStrike">
                     <a:solidFill>
                       <a:srgbClr val="5B6B70"/>
                     </a:solidFill>
@@ -2614,7 +2614,7 @@
                   </a:defRPr>
                 </a:pPr>
                 <a:r>
-                  <a:rPr sz="900" b="0" i="0" u="none" strike="noStrike">
+                  <a:rPr lang="en-GB" sz="900" b="0" i="0" u="none" strike="noStrike">
                     <a:solidFill>
                       <a:srgbClr val="5B6B70"/>
                     </a:solidFill>
@@ -2725,7 +2725,7 @@
               </a:defRPr>
             </a:pPr>
             <a:r>
-              <a:rPr sz="1200" b="0" i="0" u="none" strike="noStrike">
+              <a:rPr lang="en-GB" sz="1200" b="0" i="0" u="none" strike="noStrike">
                 <a:solidFill>
                   <a:srgbClr val="12262B"/>
                 </a:solidFill>
@@ -10117,69 +10117,6 @@
       </p:sp>
       <p:sp>
         <p:nvSpPr>
-          <p:cNvPr id="200" name="Shape 198"/>
-          <p:cNvSpPr/>
-          <p:nvPr/>
-        </p:nvSpPr>
-        <p:spPr>
-          <a:xfrm>
-            <a:off x="9509760" y="1234440"/>
-            <a:ext cx="1097280" cy="0"/>
-          </a:xfrm>
-          <a:prstGeom prst="line">
-            <a:avLst/>
-          </a:prstGeom>
-          <a:noFill/>
-          <a:ln w="31750">
-            <a:solidFill>
-              <a:srgbClr val="14A6B0"/>
-            </a:solidFill>
-            <a:prstDash val="solid"/>
-            <a:tailEnd type="triangle"/>
-          </a:ln>
-        </p:spPr>
-      </p:sp>
-      <p:sp>
-        <p:nvSpPr>
-          <p:cNvPr id="201" name="Text 199"/>
-          <p:cNvSpPr/>
-          <p:nvPr/>
-        </p:nvSpPr>
-        <p:spPr>
-          <a:xfrm>
-            <a:off x="10607040" y="1051560"/>
-            <a:ext cx="1280160" cy="365760"/>
-          </a:xfrm>
-          <a:prstGeom prst="rect">
-            <a:avLst/>
-          </a:prstGeom>
-          <a:noFill/>
-          <a:ln/>
-        </p:spPr>
-        <p:txBody>
-          <a:bodyPr wrap="square" lIns="0" tIns="0" rIns="0" bIns="0" rtlCol="0" anchor="ctr"/>
-          <a:lstStyle/>
-          <a:p>
-            <a:pPr marL="0" indent="0">
-              <a:buNone/>
-            </a:pPr>
-            <a:r>
-              <a:rPr lang="en-US" sz="1200" i="1" dirty="0">
-                <a:solidFill>
-                  <a:srgbClr val="DCEDEE"/>
-                </a:solidFill>
-                <a:latin typeface="Calibri" pitchFamily="34" charset="0"/>
-                <a:ea typeface="Calibri" pitchFamily="34" charset="-122"/>
-                <a:cs typeface="Calibri" pitchFamily="34" charset="-120"/>
-              </a:rPr>
-              <a:t>model</a:t>
-            </a:r>
-            <a:endParaRPr lang="en-US" sz="1200" dirty="0"/>
-          </a:p>
-        </p:txBody>
-      </p:sp>
-      <p:sp>
-        <p:nvSpPr>
           <p:cNvPr id="202" name="Text 200"/>
           <p:cNvSpPr/>
           <p:nvPr/>
@@ -10633,9 +10570,8 @@
                 <a:ea typeface="Calibri" pitchFamily="34" charset="-122"/>
                 <a:cs typeface="Calibri" pitchFamily="34" charset="-120"/>
               </a:rPr>
-              <a:t>Outputs a probability of recurrence between 0 and 1, then thresholds it into a class.</a:t>
-            </a:r>
-            <a:endParaRPr lang="en-US" sz="1550" dirty="0"/>
+              <a:t>Takes linear combination of gene expression -&gt; sigmoid function</a:t>
+            </a:r>
           </a:p>
           <a:p>
             <a:pPr marL="203200" indent="-203200">
@@ -10654,9 +10590,8 @@
                 <a:ea typeface="Calibri" pitchFamily="34" charset="-122"/>
                 <a:cs typeface="Calibri" pitchFamily="34" charset="-120"/>
               </a:rPr>
-              <a:t>Draws a linear decision boundary — a weighted sum of genes.</a:t>
-            </a:r>
-            <a:endParaRPr lang="en-US" sz="1550" dirty="0"/>
+              <a:t>Outputs a probability of recurrence between 0 and 1, then thresholds it into a class.</a:t>
+            </a:r>
           </a:p>
           <a:p>
             <a:pPr marL="203200" indent="-203200">
@@ -10672,10 +10607,9 @@
                   <a:srgbClr val="12262B"/>
                 </a:solidFill>
                 <a:latin typeface="Calibri" pitchFamily="34" charset="0"/>
-                <a:ea typeface="Calibri" pitchFamily="34" charset="-122"/>
                 <a:cs typeface="Calibri" pitchFamily="34" charset="-120"/>
               </a:rPr>
-              <a:t>Each gene gets a coefficient: positive pushes toward recurrence, negative away.</a:t>
+              <a:t>The model is uncertain around zero </a:t>
             </a:r>
             <a:endParaRPr lang="en-US" sz="1550" dirty="0"/>
           </a:p>
@@ -10688,15 +10622,77 @@
               <a:buChar char="•"/>
             </a:pPr>
             <a:r>
-              <a:rPr lang="en-US" sz="1550" b="1" dirty="0">
-                <a:solidFill>
-                  <a:srgbClr val="0E7C86"/>
+              <a:rPr lang="en-US" sz="1550" dirty="0">
+                <a:solidFill>
+                  <a:srgbClr val="12262B"/>
                 </a:solidFill>
                 <a:latin typeface="Calibri" pitchFamily="34" charset="0"/>
                 <a:ea typeface="Calibri" pitchFamily="34" charset="-122"/>
                 <a:cs typeface="Calibri" pitchFamily="34" charset="-120"/>
               </a:rPr>
-              <a:t>Interpretable, fast, and — crucially in p ≫ n — hard to overfit when regularised.</a:t>
+              <a:t>Each gene gets a coefficient: positive pushes toward recurrence, negative away.</a:t>
+            </a:r>
+            <a:endParaRPr lang="en-US" sz="1550" dirty="0"/>
+          </a:p>
+          <a:p>
+            <a:pPr marL="203200" indent="-203200">
+              <a:spcAft>
+                <a:spcPts val="1300"/>
+              </a:spcAft>
+              <a:buSzPct val="100000"/>
+              <a:buChar char="•"/>
+            </a:pPr>
+            <a:r>
+              <a:rPr lang="en-US" sz="1550" b="1" dirty="0">
+                <a:solidFill>
+                  <a:srgbClr val="0E7C86"/>
+                </a:solidFill>
+                <a:latin typeface="Calibri" pitchFamily="34" charset="0"/>
+                <a:ea typeface="Calibri" pitchFamily="34" charset="-122"/>
+                <a:cs typeface="Calibri" pitchFamily="34" charset="-120"/>
+              </a:rPr>
+              <a:t>Interpretable, fast, and — crucially in p ≫ n — hard to overfit when </a:t>
+            </a:r>
+            <a:r>
+              <a:rPr lang="en-US" sz="1550" b="1" dirty="0" err="1">
+                <a:solidFill>
+                  <a:srgbClr val="0E7C86"/>
+                </a:solidFill>
+                <a:latin typeface="Calibri" pitchFamily="34" charset="0"/>
+                <a:ea typeface="Calibri" pitchFamily="34" charset="-122"/>
+                <a:cs typeface="Calibri" pitchFamily="34" charset="-120"/>
+              </a:rPr>
+              <a:t>regularised</a:t>
+            </a:r>
+            <a:r>
+              <a:rPr lang="en-US" sz="1550" b="1" dirty="0">
+                <a:solidFill>
+                  <a:srgbClr val="0E7C86"/>
+                </a:solidFill>
+                <a:latin typeface="Calibri" pitchFamily="34" charset="0"/>
+                <a:ea typeface="Calibri" pitchFamily="34" charset="-122"/>
+                <a:cs typeface="Calibri" pitchFamily="34" charset="-120"/>
+              </a:rPr>
+              <a:t>.</a:t>
+            </a:r>
+          </a:p>
+          <a:p>
+            <a:pPr marL="203200" indent="-203200">
+              <a:spcAft>
+                <a:spcPts val="1300"/>
+              </a:spcAft>
+              <a:buSzPct val="100000"/>
+              <a:buChar char="•"/>
+            </a:pPr>
+            <a:r>
+              <a:rPr lang="en-US" sz="1550" b="1" dirty="0">
+                <a:solidFill>
+                  <a:srgbClr val="0E7C86"/>
+                </a:solidFill>
+                <a:latin typeface="Calibri" pitchFamily="34" charset="0"/>
+                <a:cs typeface="Calibri" pitchFamily="34" charset="-120"/>
+              </a:rPr>
+              <a:t>Very often, more complex model just leads to overfitting</a:t>
             </a:r>
             <a:endParaRPr lang="en-US" sz="1550" dirty="0"/>
           </a:p>
@@ -10706,10 +10702,16 @@
         <p:nvGraphicFramePr>
           <p:cNvPr id="8" name="Chart 0"/>
           <p:cNvGraphicFramePr/>
-          <p:nvPr/>
+          <p:nvPr>
+            <p:extLst>
+              <p:ext uri="{D42A27DB-BD31-4B8C-83A1-F6EECF244321}">
+                <p14:modId xmlns:p14="http://schemas.microsoft.com/office/powerpoint/2010/main" val="4003309529"/>
+              </p:ext>
+            </p:extLst>
+          </p:nvPr>
         </p:nvGraphicFramePr>
         <p:xfrm>
-          <a:off x="6400800" y="2194560"/>
+          <a:off x="6400800" y="1485900"/>
           <a:ext cx="5120640" cy="3291840"/>
         </p:xfrm>
         <a:graphic>
@@ -10718,6 +10720,36 @@
           </a:graphicData>
         </a:graphic>
       </p:graphicFrame>
+      <p:pic>
+        <p:nvPicPr>
+          <p:cNvPr id="9" name="Picture 8">
+            <a:extLst>
+              <a:ext uri="{FF2B5EF4-FFF2-40B4-BE49-F238E27FC236}">
+                <a16:creationId xmlns:a16="http://schemas.microsoft.com/office/drawing/2014/main" id="{80451C51-49FC-72BF-123B-580C98C7A079}"/>
+              </a:ext>
+            </a:extLst>
+          </p:cNvPr>
+          <p:cNvPicPr>
+            <a:picLocks noChangeAspect="1"/>
+          </p:cNvPicPr>
+          <p:nvPr/>
+        </p:nvPicPr>
+        <p:blipFill>
+          <a:blip r:embed="rId4"/>
+          <a:stretch>
+            <a:fillRect/>
+          </a:stretch>
+        </p:blipFill>
+        <p:spPr>
+          <a:xfrm>
+            <a:off x="6989379" y="4907630"/>
+            <a:ext cx="4360545" cy="1703482"/>
+          </a:xfrm>
+          <a:prstGeom prst="rect">
+            <a:avLst/>
+          </a:prstGeom>
+        </p:spPr>
+      </p:pic>
     </p:spTree>
   </p:cSld>
   <p:clrMapOvr>
@@ -10988,6 +11020,45 @@
               </a:rPr>
               <a:t>The threshold (default 0.5) is a choice — we can move it to trade off the two error types.</a:t>
             </a:r>
+          </a:p>
+          <a:p>
+            <a:pPr marL="203200" indent="-203200">
+              <a:spcAft>
+                <a:spcPts val="1200"/>
+              </a:spcAft>
+              <a:buSzPct val="100000"/>
+              <a:buChar char="•"/>
+            </a:pPr>
+            <a:r>
+              <a:rPr lang="en-US" sz="1600" b="1" dirty="0">
+                <a:solidFill>
+                  <a:srgbClr val="C2772B"/>
+                </a:solidFill>
+                <a:latin typeface="Calibri" pitchFamily="34" charset="0"/>
+                <a:cs typeface="Calibri" pitchFamily="34" charset="-120"/>
+              </a:rPr>
+              <a:t>THE WAY YOU MOVE IT DEPENDS ON WHAT IS WORSE: </a:t>
+            </a:r>
+            <a:r>
+              <a:rPr lang="en-US" sz="1600" b="1" dirty="0" err="1">
+                <a:solidFill>
+                  <a:srgbClr val="C2772B"/>
+                </a:solidFill>
+                <a:latin typeface="Calibri" pitchFamily="34" charset="0"/>
+                <a:cs typeface="Calibri" pitchFamily="34" charset="-120"/>
+              </a:rPr>
+              <a:t>mislabelling</a:t>
+            </a:r>
+            <a:r>
+              <a:rPr lang="en-US" sz="1600" b="1" dirty="0">
+                <a:solidFill>
+                  <a:srgbClr val="C2772B"/>
+                </a:solidFill>
+                <a:latin typeface="Calibri" pitchFamily="34" charset="0"/>
+                <a:cs typeface="Calibri" pitchFamily="34" charset="-120"/>
+              </a:rPr>
+              <a:t> recurrence or no recurrence</a:t>
+            </a:r>
             <a:endParaRPr lang="en-US" sz="1600" dirty="0"/>
           </a:p>
         </p:txBody>
@@ -12682,7 +12753,7 @@
                 <a:ea typeface="Calibri" pitchFamily="34" charset="-122"/>
                 <a:cs typeface="Calibri" pitchFamily="34" charset="-120"/>
               </a:rPr>
-              <a:t>The baseline is the yardstick: any fancy model must beat a well-built Logistic Regression to justify itself.</a:t>
+              <a:t>The baseline is the important: any fancy model must beat a well-built Logistic Regression to justify itself.</a:t>
             </a:r>
             <a:endParaRPr lang="en-US" sz="1600" dirty="0"/>
           </a:p>
@@ -13153,7 +13224,7 @@
                 <a:ea typeface="Calibri" pitchFamily="34" charset="-122"/>
                 <a:cs typeface="Calibri" pitchFamily="34" charset="-120"/>
               </a:rPr>
-              <a:t>p ≫ n means a plain Logistic Regression can fit the training data perfectly — and generalise terribly.</a:t>
+              <a:t>p ≫ n means a plain Logistic Regression can fit the training data perfectly, and generalise terribly.</a:t>
             </a:r>
             <a:endParaRPr lang="en-US" sz="1600" dirty="0"/>
           </a:p>
@@ -13217,6 +13288,45 @@
                 <a:cs typeface="Calibri" pitchFamily="34" charset="-120"/>
               </a:rPr>
               <a:t>The single most important tool for making linear models work in transcriptomics.</a:t>
+            </a:r>
+          </a:p>
+          <a:p>
+            <a:pPr marL="203200" indent="-203200">
+              <a:spcAft>
+                <a:spcPts val="1400"/>
+              </a:spcAft>
+              <a:buSzPct val="100000"/>
+              <a:buChar char="•"/>
+            </a:pPr>
+            <a:r>
+              <a:rPr lang="en-US" sz="1600" b="1" dirty="0" err="1">
+                <a:solidFill>
+                  <a:srgbClr val="0E7C86"/>
+                </a:solidFill>
+                <a:latin typeface="Calibri" pitchFamily="34" charset="0"/>
+                <a:cs typeface="Calibri" pitchFamily="34" charset="-120"/>
+              </a:rPr>
+              <a:t>Regularisation</a:t>
+            </a:r>
+            <a:r>
+              <a:rPr lang="en-US" sz="1600" b="1" dirty="0">
+                <a:solidFill>
+                  <a:srgbClr val="0E7C86"/>
+                </a:solidFill>
+                <a:latin typeface="Calibri" pitchFamily="34" charset="0"/>
+                <a:cs typeface="Calibri" pitchFamily="34" charset="-120"/>
+              </a:rPr>
+              <a:t> makes your models perform worse: the tiny improvement of performance might just be the overfitting, the </a:t>
+            </a:r>
+            <a:r>
+              <a:rPr lang="en-US" sz="1600" b="1" dirty="0" err="1">
+                <a:solidFill>
+                  <a:srgbClr val="0E7C86"/>
+                </a:solidFill>
+                <a:latin typeface="Calibri" pitchFamily="34" charset="0"/>
+                <a:cs typeface="Calibri" pitchFamily="34" charset="-120"/>
+              </a:rPr>
+              <a:t>memorisation</a:t>
             </a:r>
             <a:endParaRPr lang="en-US" sz="1600" dirty="0"/>
           </a:p>
@@ -15107,7 +15217,7 @@
         </p:nvSpPr>
         <p:spPr>
           <a:xfrm>
-            <a:off x="11247120" y="6473952"/>
+            <a:off x="11247120" y="5468112"/>
             <a:ext cx="365760" cy="274320"/>
           </a:xfrm>
           <a:prstGeom prst="rect">
@@ -15175,7 +15285,7 @@
                 <a:ea typeface="Calibri" pitchFamily="34" charset="-122"/>
                 <a:cs typeface="Calibri" pitchFamily="34" charset="-120"/>
               </a:rPr>
-              <a:t>The LASSO penalty drives many coefficients exactly to zero — it selects a small gene panel automatically.</a:t>
+              <a:t>The LASSO penalty drives many coefficients exactly to zero: it selects a small gene panel automatically (feature extraction!)</a:t>
             </a:r>
             <a:endParaRPr lang="en-US" sz="1550" dirty="0"/>
           </a:p>
@@ -15217,7 +15327,7 @@
                 <a:ea typeface="Calibri" pitchFamily="34" charset="-122"/>
                 <a:cs typeface="Calibri" pitchFamily="34" charset="-120"/>
               </a:rPr>
-              <a:t>Caveat (Lecture 1): among correlated genes, LASSO keeps one and drops the rest — selection is unstable.</a:t>
+              <a:t>Caveat: among correlated genes, LASSO keeps one and drops the rest, thus selection is unstable.</a:t>
             </a:r>
             <a:endParaRPr lang="en-US" sz="1550" dirty="0"/>
           </a:p>
@@ -15238,7 +15348,7 @@
                 <a:ea typeface="Calibri" pitchFamily="34" charset="-122"/>
                 <a:cs typeface="Calibri" pitchFamily="34" charset="-120"/>
               </a:rPr>
-              <a:t>So a LASSO panel is a hypothesis, not a proven causal gene set.</a:t>
+              <a:t>So a LASSO panel is a hypothesis, not a proven causal gene set: DO NOT OVERINTERPRET LASSO GENES</a:t>
             </a:r>
             <a:endParaRPr lang="en-US" sz="1550" dirty="0"/>
           </a:p>
@@ -15252,7 +15362,7 @@
         </p:nvSpPr>
         <p:spPr>
           <a:xfrm>
-            <a:off x="6766560" y="2286000"/>
+            <a:off x="6766560" y="1280160"/>
             <a:ext cx="4572000" cy="3108960"/>
           </a:xfrm>
           <a:prstGeom prst="rect">
@@ -15283,7 +15393,7 @@
         </p:nvCxnSpPr>
         <p:spPr>
           <a:xfrm>
-            <a:off x="6896560" y="3902659"/>
+            <a:off x="6896560" y="2896819"/>
             <a:ext cx="4352000" cy="0"/>
           </a:xfrm>
           <a:prstGeom prst="line">
@@ -15305,7 +15415,7 @@
         </p:nvSpPr>
         <p:spPr>
           <a:xfrm>
-            <a:off x="6896560" y="2993330"/>
+            <a:off x="6896560" y="1987490"/>
             <a:ext cx="4352000" cy="909329"/>
           </a:xfrm>
           <a:custGeom>
@@ -15382,7 +15492,7 @@
         </p:nvSpPr>
         <p:spPr>
           <a:xfrm>
-            <a:off x="6896560" y="3902659"/>
+            <a:off x="6896560" y="2896819"/>
             <a:ext cx="4352000" cy="631150"/>
           </a:xfrm>
           <a:custGeom>
@@ -15459,7 +15569,7 @@
         </p:nvSpPr>
         <p:spPr>
           <a:xfrm>
-            <a:off x="6896560" y="3286662"/>
+            <a:off x="6896560" y="2280822"/>
             <a:ext cx="4352000" cy="615997"/>
           </a:xfrm>
           <a:custGeom>
@@ -15536,7 +15646,7 @@
         </p:nvSpPr>
         <p:spPr>
           <a:xfrm>
-            <a:off x="6896560" y="3902659"/>
+            <a:off x="6896560" y="2896819"/>
             <a:ext cx="4352000" cy="833118"/>
           </a:xfrm>
           <a:custGeom>
@@ -15613,7 +15723,7 @@
         </p:nvSpPr>
         <p:spPr>
           <a:xfrm>
-            <a:off x="6896560" y="3095996"/>
+            <a:off x="6896560" y="2090156"/>
             <a:ext cx="4352000" cy="806663"/>
           </a:xfrm>
           <a:custGeom>
@@ -15690,7 +15800,7 @@
         </p:nvSpPr>
         <p:spPr>
           <a:xfrm>
-            <a:off x="6896560" y="3902659"/>
+            <a:off x="6896560" y="2896819"/>
             <a:ext cx="4352000" cy="479674"/>
           </a:xfrm>
           <a:custGeom>
@@ -15767,7 +15877,7 @@
         </p:nvSpPr>
         <p:spPr>
           <a:xfrm>
-            <a:off x="6896560" y="3462661"/>
+            <a:off x="6896560" y="2456821"/>
             <a:ext cx="4352000" cy="439998"/>
           </a:xfrm>
           <a:custGeom>
@@ -15844,7 +15954,7 @@
         </p:nvSpPr>
         <p:spPr>
           <a:xfrm>
-            <a:off x="6896560" y="3902659"/>
+            <a:off x="6896560" y="2896819"/>
             <a:ext cx="4352000" cy="605904"/>
           </a:xfrm>
           <a:custGeom>
@@ -15921,7 +16031,7 @@
         </p:nvSpPr>
         <p:spPr>
           <a:xfrm>
-            <a:off x="6896560" y="3242662"/>
+            <a:off x="6896560" y="2236822"/>
             <a:ext cx="4352000" cy="659997"/>
           </a:xfrm>
           <a:custGeom>
@@ -15998,7 +16108,7 @@
         </p:nvSpPr>
         <p:spPr>
           <a:xfrm>
-            <a:off x="6896560" y="3902659"/>
+            <a:off x="6896560" y="2896819"/>
             <a:ext cx="4352000" cy="353444"/>
           </a:xfrm>
           <a:custGeom>
@@ -16075,7 +16185,7 @@
         </p:nvSpPr>
         <p:spPr>
           <a:xfrm>
-            <a:off x="6896560" y="2655998"/>
+            <a:off x="6896560" y="1650158"/>
             <a:ext cx="4352000" cy="560997"/>
           </a:xfrm>
           <a:custGeom>
@@ -16152,7 +16262,7 @@
         </p:nvSpPr>
         <p:spPr>
           <a:xfrm>
-            <a:off x="6896560" y="4402530"/>
+            <a:off x="6896560" y="3396690"/>
             <a:ext cx="4352000" cy="408985"/>
           </a:xfrm>
           <a:custGeom>
@@ -16229,7 +16339,7 @@
         </p:nvSpPr>
         <p:spPr>
           <a:xfrm>
-            <a:off x="6896560" y="3022663"/>
+            <a:off x="6896560" y="2016823"/>
             <a:ext cx="4352000" cy="395998"/>
           </a:xfrm>
           <a:custGeom>
@@ -16306,7 +16416,7 @@
         </p:nvSpPr>
         <p:spPr>
           <a:xfrm>
-            <a:off x="9038560" y="2406000"/>
+            <a:off x="9038560" y="1400160"/>
             <a:ext cx="2150000" cy="246380"/>
           </a:xfrm>
           <a:prstGeom prst="rect">
@@ -16342,7 +16452,7 @@
         </p:nvSpPr>
         <p:spPr>
           <a:xfrm>
-            <a:off x="6966560" y="5094960"/>
+            <a:off x="6966560" y="4089120"/>
             <a:ext cx="2400000" cy="246380"/>
           </a:xfrm>
           <a:prstGeom prst="rect">
@@ -16378,7 +16488,7 @@
         </p:nvSpPr>
         <p:spPr>
           <a:xfrm>
-            <a:off x="6766560" y="5468112"/>
+            <a:off x="6766560" y="4462272"/>
             <a:ext cx="4572000" cy="274320"/>
           </a:xfrm>
           <a:prstGeom prst="rect">
@@ -16423,7 +16533,7 @@
         </p:nvSpPr>
         <p:spPr>
           <a:xfrm rot="16200000">
-            <a:off x="6191531" y="3655814"/>
+            <a:off x="6191531" y="2649974"/>
             <a:ext cx="682110" cy="369332"/>
           </a:xfrm>
           <a:prstGeom prst="rect">
@@ -16441,6 +16551,148 @@
               <a:rPr lang="en-IT" dirty="0"/>
               <a:t>Coeff</a:t>
             </a:r>
+          </a:p>
+        </p:txBody>
+      </p:sp>
+      <p:pic>
+        <p:nvPicPr>
+          <p:cNvPr id="10" name="Picture 9">
+            <a:extLst>
+              <a:ext uri="{FF2B5EF4-FFF2-40B4-BE49-F238E27FC236}">
+                <a16:creationId xmlns:a16="http://schemas.microsoft.com/office/drawing/2014/main" id="{D5F6711D-4FA0-56BA-8518-C8557738C23C}"/>
+              </a:ext>
+            </a:extLst>
+          </p:cNvPr>
+          <p:cNvPicPr>
+            <a:picLocks noChangeAspect="1"/>
+          </p:cNvPicPr>
+          <p:nvPr/>
+        </p:nvPicPr>
+        <p:blipFill>
+          <a:blip r:embed="rId3"/>
+          <a:stretch>
+            <a:fillRect/>
+          </a:stretch>
+        </p:blipFill>
+        <p:spPr>
+          <a:xfrm>
+            <a:off x="5792164" y="4989461"/>
+            <a:ext cx="5000910" cy="436761"/>
+          </a:xfrm>
+          <a:prstGeom prst="rect">
+            <a:avLst/>
+          </a:prstGeom>
+        </p:spPr>
+      </p:pic>
+      <p:pic>
+        <p:nvPicPr>
+          <p:cNvPr id="11" name="Picture 10">
+            <a:extLst>
+              <a:ext uri="{FF2B5EF4-FFF2-40B4-BE49-F238E27FC236}">
+                <a16:creationId xmlns:a16="http://schemas.microsoft.com/office/drawing/2014/main" id="{CDBBB78F-AC18-4939-A748-017B4594E2D7}"/>
+              </a:ext>
+            </a:extLst>
+          </p:cNvPr>
+          <p:cNvPicPr>
+            <a:picLocks noChangeAspect="1"/>
+          </p:cNvPicPr>
+          <p:nvPr/>
+        </p:nvPicPr>
+        <p:blipFill>
+          <a:blip r:embed="rId4"/>
+          <a:stretch>
+            <a:fillRect/>
+          </a:stretch>
+        </p:blipFill>
+        <p:spPr>
+          <a:xfrm>
+            <a:off x="7513846" y="5319455"/>
+            <a:ext cx="1986456" cy="864476"/>
+          </a:xfrm>
+          <a:prstGeom prst="rect">
+            <a:avLst/>
+          </a:prstGeom>
+        </p:spPr>
+      </p:pic>
+      <p:pic>
+        <p:nvPicPr>
+          <p:cNvPr id="12" name="Picture 11">
+            <a:extLst>
+              <a:ext uri="{FF2B5EF4-FFF2-40B4-BE49-F238E27FC236}">
+                <a16:creationId xmlns:a16="http://schemas.microsoft.com/office/drawing/2014/main" id="{C2CD6A4B-FEC0-0D21-8BD1-CDCAD72869A5}"/>
+              </a:ext>
+            </a:extLst>
+          </p:cNvPr>
+          <p:cNvPicPr>
+            <a:picLocks noChangeAspect="1"/>
+          </p:cNvPicPr>
+          <p:nvPr/>
+        </p:nvPicPr>
+        <p:blipFill>
+          <a:blip r:embed="rId5"/>
+          <a:stretch>
+            <a:fillRect/>
+          </a:stretch>
+        </p:blipFill>
+        <p:spPr>
+          <a:xfrm>
+            <a:off x="5941849" y="6075812"/>
+            <a:ext cx="4701540" cy="742884"/>
+          </a:xfrm>
+          <a:prstGeom prst="rect">
+            <a:avLst/>
+          </a:prstGeom>
+        </p:spPr>
+      </p:pic>
+      <p:sp>
+        <p:nvSpPr>
+          <p:cNvPr id="13" name="Rectangle 12">
+            <a:extLst>
+              <a:ext uri="{FF2B5EF4-FFF2-40B4-BE49-F238E27FC236}">
+                <a16:creationId xmlns:a16="http://schemas.microsoft.com/office/drawing/2014/main" id="{9152E74B-11B8-9D92-6A38-FD650ACECAE8}"/>
+              </a:ext>
+            </a:extLst>
+          </p:cNvPr>
+          <p:cNvSpPr/>
+          <p:nvPr/>
+        </p:nvSpPr>
+        <p:spPr>
+          <a:xfrm>
+            <a:off x="9774621" y="5948855"/>
+            <a:ext cx="868768" cy="909145"/>
+          </a:xfrm>
+          <a:prstGeom prst="rect">
+            <a:avLst/>
+          </a:prstGeom>
+          <a:noFill/>
+          <a:ln>
+            <a:solidFill>
+              <a:srgbClr val="FF0000"/>
+            </a:solidFill>
+          </a:ln>
+        </p:spPr>
+        <p:style>
+          <a:lnRef idx="2">
+            <a:schemeClr val="accent1">
+              <a:shade val="15000"/>
+            </a:schemeClr>
+          </a:lnRef>
+          <a:fillRef idx="1">
+            <a:schemeClr val="accent1"/>
+          </a:fillRef>
+          <a:effectRef idx="0">
+            <a:schemeClr val="accent1"/>
+          </a:effectRef>
+          <a:fontRef idx="minor">
+            <a:schemeClr val="lt1"/>
+          </a:fontRef>
+        </p:style>
+        <p:txBody>
+          <a:bodyPr rtlCol="0" anchor="ctr"/>
+          <a:lstStyle/>
+          <a:p>
+            <a:pPr algn="ctr"/>
+            <a:endParaRPr lang="en-IT"/>
           </a:p>
         </p:txBody>
       </p:sp>
@@ -16747,7 +16999,7 @@
         </p:nvSpPr>
         <p:spPr>
           <a:xfrm>
-            <a:off x="6858000" y="2377440"/>
+            <a:off x="6710856" y="1536192"/>
             <a:ext cx="2286000" cy="2468880"/>
           </a:xfrm>
           <a:prstGeom prst="rect">
@@ -16772,7 +17024,7 @@
         </p:nvSpPr>
         <p:spPr>
           <a:xfrm>
-            <a:off x="6858000" y="4892040"/>
+            <a:off x="6710856" y="4050792"/>
             <a:ext cx="2286000" cy="274320"/>
           </a:xfrm>
           <a:prstGeom prst="rect">
@@ -16811,7 +17063,7 @@
         </p:nvSpPr>
         <p:spPr>
           <a:xfrm>
-            <a:off x="8631936" y="3465576"/>
+            <a:off x="8484792" y="2624328"/>
             <a:ext cx="292608" cy="292608"/>
           </a:xfrm>
           <a:prstGeom prst="ellipse">
@@ -16836,7 +17088,7 @@
         </p:nvSpPr>
         <p:spPr>
           <a:xfrm>
-            <a:off x="8094876" y="4204775"/>
+            <a:off x="7947732" y="3363527"/>
             <a:ext cx="292608" cy="292608"/>
           </a:xfrm>
           <a:prstGeom prst="ellipse">
@@ -16861,7 +17113,7 @@
         </p:nvSpPr>
         <p:spPr>
           <a:xfrm>
-            <a:off x="7225896" y="3922426"/>
+            <a:off x="7078752" y="3081178"/>
             <a:ext cx="292608" cy="292608"/>
           </a:xfrm>
           <a:prstGeom prst="ellipse">
@@ -16886,7 +17138,7 @@
         </p:nvSpPr>
         <p:spPr>
           <a:xfrm>
-            <a:off x="7225896" y="3008726"/>
+            <a:off x="7078752" y="2167478"/>
             <a:ext cx="292608" cy="292608"/>
           </a:xfrm>
           <a:prstGeom prst="ellipse">
@@ -16911,7 +17163,7 @@
         </p:nvSpPr>
         <p:spPr>
           <a:xfrm>
-            <a:off x="8094876" y="2726377"/>
+            <a:off x="7947732" y="1885129"/>
             <a:ext cx="292608" cy="292608"/>
           </a:xfrm>
           <a:prstGeom prst="ellipse">
@@ -16936,7 +17188,7 @@
         </p:nvSpPr>
         <p:spPr>
           <a:xfrm>
-            <a:off x="6858000" y="2121408"/>
+            <a:off x="6710856" y="1280160"/>
             <a:ext cx="2286000" cy="228600"/>
           </a:xfrm>
           <a:prstGeom prst="rect">
@@ -16975,7 +17227,7 @@
         </p:nvSpPr>
         <p:spPr>
           <a:xfrm>
-            <a:off x="9326880" y="2377440"/>
+            <a:off x="9179736" y="1536192"/>
             <a:ext cx="2286000" cy="2468880"/>
           </a:xfrm>
           <a:prstGeom prst="rect">
@@ -17000,7 +17252,7 @@
         </p:nvSpPr>
         <p:spPr>
           <a:xfrm>
-            <a:off x="9326880" y="4892040"/>
+            <a:off x="9179736" y="4050792"/>
             <a:ext cx="2286000" cy="274320"/>
           </a:xfrm>
           <a:prstGeom prst="rect">
@@ -17039,7 +17291,7 @@
         </p:nvSpPr>
         <p:spPr>
           <a:xfrm>
-            <a:off x="11100816" y="3465576"/>
+            <a:off x="10953672" y="2624328"/>
             <a:ext cx="292608" cy="292608"/>
           </a:xfrm>
           <a:prstGeom prst="ellipse">
@@ -17064,7 +17316,7 @@
         </p:nvSpPr>
         <p:spPr>
           <a:xfrm>
-            <a:off x="10563756" y="4204775"/>
+            <a:off x="10416612" y="3363527"/>
             <a:ext cx="292608" cy="292608"/>
           </a:xfrm>
           <a:prstGeom prst="ellipse">
@@ -17089,7 +17341,7 @@
         </p:nvSpPr>
         <p:spPr>
           <a:xfrm>
-            <a:off x="9694776" y="3922426"/>
+            <a:off x="9547632" y="3081178"/>
             <a:ext cx="292608" cy="292608"/>
           </a:xfrm>
           <a:prstGeom prst="ellipse">
@@ -17114,7 +17366,7 @@
         </p:nvSpPr>
         <p:spPr>
           <a:xfrm>
-            <a:off x="9694776" y="3008726"/>
+            <a:off x="9547632" y="2167478"/>
             <a:ext cx="292608" cy="292608"/>
           </a:xfrm>
           <a:prstGeom prst="ellipse">
@@ -17139,7 +17391,7 @@
         </p:nvSpPr>
         <p:spPr>
           <a:xfrm>
-            <a:off x="10563756" y="2726377"/>
+            <a:off x="10416612" y="1885129"/>
             <a:ext cx="292608" cy="292608"/>
           </a:xfrm>
           <a:prstGeom prst="ellipse">
@@ -17164,7 +17416,7 @@
         </p:nvSpPr>
         <p:spPr>
           <a:xfrm>
-            <a:off x="9326880" y="2121408"/>
+            <a:off x="9179736" y="1280160"/>
             <a:ext cx="2286000" cy="228600"/>
           </a:xfrm>
           <a:prstGeom prst="rect">
@@ -17192,6 +17444,148 @@
               <a:t>correlated gene cluster</a:t>
             </a:r>
             <a:endParaRPr lang="en-US" sz="900" dirty="0"/>
+          </a:p>
+        </p:txBody>
+      </p:sp>
+      <p:pic>
+        <p:nvPicPr>
+          <p:cNvPr id="25" name="Picture 24">
+            <a:extLst>
+              <a:ext uri="{FF2B5EF4-FFF2-40B4-BE49-F238E27FC236}">
+                <a16:creationId xmlns:a16="http://schemas.microsoft.com/office/drawing/2014/main" id="{DD4D7FC9-BD46-28B2-447A-93BE41DB33FE}"/>
+              </a:ext>
+            </a:extLst>
+          </p:cNvPr>
+          <p:cNvPicPr>
+            <a:picLocks noChangeAspect="1"/>
+          </p:cNvPicPr>
+          <p:nvPr/>
+        </p:nvPicPr>
+        <p:blipFill>
+          <a:blip r:embed="rId3"/>
+          <a:stretch>
+            <a:fillRect/>
+          </a:stretch>
+        </p:blipFill>
+        <p:spPr>
+          <a:xfrm>
+            <a:off x="6464826" y="4559576"/>
+            <a:ext cx="5000910" cy="436761"/>
+          </a:xfrm>
+          <a:prstGeom prst="rect">
+            <a:avLst/>
+          </a:prstGeom>
+        </p:spPr>
+      </p:pic>
+      <p:pic>
+        <p:nvPicPr>
+          <p:cNvPr id="26" name="Picture 25">
+            <a:extLst>
+              <a:ext uri="{FF2B5EF4-FFF2-40B4-BE49-F238E27FC236}">
+                <a16:creationId xmlns:a16="http://schemas.microsoft.com/office/drawing/2014/main" id="{F5AE3C37-D64B-7D32-DE63-3486B7A463DA}"/>
+              </a:ext>
+            </a:extLst>
+          </p:cNvPr>
+          <p:cNvPicPr>
+            <a:picLocks noChangeAspect="1"/>
+          </p:cNvPicPr>
+          <p:nvPr/>
+        </p:nvPicPr>
+        <p:blipFill>
+          <a:blip r:embed="rId4"/>
+          <a:stretch>
+            <a:fillRect/>
+          </a:stretch>
+        </p:blipFill>
+        <p:spPr>
+          <a:xfrm>
+            <a:off x="8186508" y="4889570"/>
+            <a:ext cx="1986456" cy="864476"/>
+          </a:xfrm>
+          <a:prstGeom prst="rect">
+            <a:avLst/>
+          </a:prstGeom>
+        </p:spPr>
+      </p:pic>
+      <p:pic>
+        <p:nvPicPr>
+          <p:cNvPr id="27" name="Picture 26">
+            <a:extLst>
+              <a:ext uri="{FF2B5EF4-FFF2-40B4-BE49-F238E27FC236}">
+                <a16:creationId xmlns:a16="http://schemas.microsoft.com/office/drawing/2014/main" id="{0611C0BB-3871-511E-43DB-A92E7B9334B8}"/>
+              </a:ext>
+            </a:extLst>
+          </p:cNvPr>
+          <p:cNvPicPr>
+            <a:picLocks noChangeAspect="1"/>
+          </p:cNvPicPr>
+          <p:nvPr/>
+        </p:nvPicPr>
+        <p:blipFill>
+          <a:blip r:embed="rId5"/>
+          <a:stretch>
+            <a:fillRect/>
+          </a:stretch>
+        </p:blipFill>
+        <p:spPr>
+          <a:xfrm>
+            <a:off x="5567680" y="5699565"/>
+            <a:ext cx="6045200" cy="850900"/>
+          </a:xfrm>
+          <a:prstGeom prst="rect">
+            <a:avLst/>
+          </a:prstGeom>
+        </p:spPr>
+      </p:pic>
+      <p:sp>
+        <p:nvSpPr>
+          <p:cNvPr id="28" name="Rectangle 27">
+            <a:extLst>
+              <a:ext uri="{FF2B5EF4-FFF2-40B4-BE49-F238E27FC236}">
+                <a16:creationId xmlns:a16="http://schemas.microsoft.com/office/drawing/2014/main" id="{A2BDD64B-D3B8-AAF9-564D-3C49F6466A27}"/>
+              </a:ext>
+            </a:extLst>
+          </p:cNvPr>
+          <p:cNvSpPr/>
+          <p:nvPr/>
+        </p:nvSpPr>
+        <p:spPr>
+          <a:xfrm>
+            <a:off x="9694148" y="5723458"/>
+            <a:ext cx="1918732" cy="909145"/>
+          </a:xfrm>
+          <a:prstGeom prst="rect">
+            <a:avLst/>
+          </a:prstGeom>
+          <a:noFill/>
+          <a:ln>
+            <a:solidFill>
+              <a:srgbClr val="FF0000"/>
+            </a:solidFill>
+          </a:ln>
+        </p:spPr>
+        <p:style>
+          <a:lnRef idx="2">
+            <a:schemeClr val="accent1">
+              <a:shade val="15000"/>
+            </a:schemeClr>
+          </a:lnRef>
+          <a:fillRef idx="1">
+            <a:schemeClr val="accent1"/>
+          </a:fillRef>
+          <a:effectRef idx="0">
+            <a:schemeClr val="accent1"/>
+          </a:effectRef>
+          <a:fontRef idx="minor">
+            <a:schemeClr val="lt1"/>
+          </a:fontRef>
+        </p:style>
+        <p:txBody>
+          <a:bodyPr rtlCol="0" anchor="ctr"/>
+          <a:lstStyle/>
+          <a:p>
+            <a:pPr algn="ctr"/>
+            <a:endParaRPr lang="en-IT"/>
           </a:p>
         </p:txBody>
       </p:sp>
@@ -17300,7 +17694,7 @@
                 <a:ea typeface="Cambria" pitchFamily="34" charset="-122"/>
                 <a:cs typeface="Cambria" pitchFamily="34" charset="-120"/>
               </a:rPr>
-              <a:t>Evaluating a classifier — accuracy is not enough</a:t>
+              <a:t>Evaluating a classifier: accuracy is not enough</a:t>
             </a:r>
             <a:endParaRPr lang="en-US" sz="3000" dirty="0"/>
           </a:p>
@@ -17421,7 +17815,7 @@
                 <a:ea typeface="Calibri" pitchFamily="34" charset="-122"/>
                 <a:cs typeface="Calibri" pitchFamily="34" charset="-120"/>
               </a:rPr>
-              <a:t>Recurrence is a minority class (Lecture 1) — accuracy is misleading.</a:t>
+              <a:t>Recurrence is a minority class: accuracy is misleading.</a:t>
             </a:r>
             <a:endParaRPr lang="en-US" sz="1600" dirty="0"/>
           </a:p>
@@ -17774,7 +18168,65 @@
                 <a:ea typeface="Calibri" pitchFamily="34" charset="-122"/>
                 <a:cs typeface="Calibri" pitchFamily="34" charset="-120"/>
               </a:rPr>
-              <a:t>Which to prioritise depends on the clinical cost asymmetry from Lecture 1.</a:t>
+              <a:t>Which to prioritise depends on the clinical cost asymmetry.</a:t>
+            </a:r>
+          </a:p>
+          <a:p>
+            <a:pPr marL="203200" indent="-203200">
+              <a:spcAft>
+                <a:spcPts val="1300"/>
+              </a:spcAft>
+              <a:buSzPct val="100000"/>
+              <a:buChar char="•"/>
+            </a:pPr>
+            <a:r>
+              <a:rPr lang="en-US" sz="1550" b="1" dirty="0">
+                <a:solidFill>
+                  <a:srgbClr val="0E7C86"/>
+                </a:solidFill>
+                <a:latin typeface="Calibri" pitchFamily="34" charset="0"/>
+                <a:cs typeface="Calibri" pitchFamily="34" charset="-120"/>
+              </a:rPr>
+              <a:t>If you want to minimize the missed recurrence, </a:t>
+            </a:r>
+            <a:r>
+              <a:rPr lang="en-US" sz="1550" b="1" dirty="0" err="1">
+                <a:solidFill>
+                  <a:srgbClr val="0E7C86"/>
+                </a:solidFill>
+                <a:latin typeface="Calibri" pitchFamily="34" charset="0"/>
+                <a:cs typeface="Calibri" pitchFamily="34" charset="-120"/>
+              </a:rPr>
+              <a:t>maximise</a:t>
+            </a:r>
+            <a:r>
+              <a:rPr lang="en-US" sz="1550" b="1" dirty="0">
+                <a:solidFill>
+                  <a:srgbClr val="0E7C86"/>
+                </a:solidFill>
+                <a:latin typeface="Calibri" pitchFamily="34" charset="0"/>
+                <a:cs typeface="Calibri" pitchFamily="34" charset="-120"/>
+              </a:rPr>
+              <a:t> recall.</a:t>
+            </a:r>
+          </a:p>
+          <a:p>
+            <a:pPr marL="203200" indent="-203200">
+              <a:spcAft>
+                <a:spcPts val="1300"/>
+              </a:spcAft>
+              <a:buSzPct val="100000"/>
+              <a:buChar char="•"/>
+            </a:pPr>
+            <a:r>
+              <a:rPr lang="en-US" sz="1550" b="1" dirty="0">
+                <a:solidFill>
+                  <a:srgbClr val="0E7C86"/>
+                </a:solidFill>
+                <a:latin typeface="Calibri" pitchFamily="34" charset="0"/>
+                <a:cs typeface="Calibri" pitchFamily="34" charset="-120"/>
+              </a:rPr>
+              <a:t>If you want to minimize over treatment, maximize precision</a:t>
             </a:r>
             <a:endParaRPr lang="en-US" sz="1550" dirty="0"/>
           </a:p>
@@ -18270,6 +18722,96 @@
           </a:p>
         </p:txBody>
       </p:sp>
+      <p:pic>
+        <p:nvPicPr>
+          <p:cNvPr id="6" name="Image 0" descr="precision.png">
+            <a:extLst>
+              <a:ext uri="{FF2B5EF4-FFF2-40B4-BE49-F238E27FC236}">
+                <a16:creationId xmlns:a16="http://schemas.microsoft.com/office/drawing/2014/main" id="{016EC64B-4B19-FE6E-7675-056F26AA30B5}"/>
+              </a:ext>
+            </a:extLst>
+          </p:cNvPr>
+          <p:cNvPicPr>
+            <a:picLocks noChangeAspect="1"/>
+          </p:cNvPicPr>
+          <p:nvPr/>
+        </p:nvPicPr>
+        <p:blipFill>
+          <a:blip r:embed="rId3"/>
+          <a:stretch>
+            <a:fillRect/>
+          </a:stretch>
+        </p:blipFill>
+        <p:spPr>
+          <a:xfrm>
+            <a:off x="3566160" y="4733490"/>
+            <a:ext cx="2286000" cy="509118"/>
+          </a:xfrm>
+          <a:prstGeom prst="rect">
+            <a:avLst/>
+          </a:prstGeom>
+        </p:spPr>
+      </p:pic>
+      <p:pic>
+        <p:nvPicPr>
+          <p:cNvPr id="22" name="Image 1" descr="recall.png">
+            <a:extLst>
+              <a:ext uri="{FF2B5EF4-FFF2-40B4-BE49-F238E27FC236}">
+                <a16:creationId xmlns:a16="http://schemas.microsoft.com/office/drawing/2014/main" id="{C32A9B48-C829-D517-0745-A508950224F7}"/>
+              </a:ext>
+            </a:extLst>
+          </p:cNvPr>
+          <p:cNvPicPr>
+            <a:picLocks noChangeAspect="1"/>
+          </p:cNvPicPr>
+          <p:nvPr/>
+        </p:nvPicPr>
+        <p:blipFill>
+          <a:blip r:embed="rId4"/>
+          <a:stretch>
+            <a:fillRect/>
+          </a:stretch>
+        </p:blipFill>
+        <p:spPr>
+          <a:xfrm>
+            <a:off x="3566160" y="5419290"/>
+            <a:ext cx="2057400" cy="524720"/>
+          </a:xfrm>
+          <a:prstGeom prst="rect">
+            <a:avLst/>
+          </a:prstGeom>
+        </p:spPr>
+      </p:pic>
+      <p:pic>
+        <p:nvPicPr>
+          <p:cNvPr id="23" name="Image 2" descr="f1.png">
+            <a:extLst>
+              <a:ext uri="{FF2B5EF4-FFF2-40B4-BE49-F238E27FC236}">
+                <a16:creationId xmlns:a16="http://schemas.microsoft.com/office/drawing/2014/main" id="{77C28FFF-963B-31BC-EA2D-CAC2014126D5}"/>
+              </a:ext>
+            </a:extLst>
+          </p:cNvPr>
+          <p:cNvPicPr>
+            <a:picLocks noChangeAspect="1"/>
+          </p:cNvPicPr>
+          <p:nvPr/>
+        </p:nvPicPr>
+        <p:blipFill>
+          <a:blip r:embed="rId5"/>
+          <a:stretch>
+            <a:fillRect/>
+          </a:stretch>
+        </p:blipFill>
+        <p:spPr>
+          <a:xfrm>
+            <a:off x="3566160" y="6105090"/>
+            <a:ext cx="3017520" cy="573133"/>
+          </a:xfrm>
+          <a:prstGeom prst="rect">
+            <a:avLst/>
+          </a:prstGeom>
+        </p:spPr>
+      </p:pic>
     </p:spTree>
   </p:cSld>
   <p:clrMapOvr>
@@ -18496,7 +19038,7 @@
                 <a:ea typeface="Calibri" pitchFamily="34" charset="-122"/>
                 <a:cs typeface="Calibri" pitchFamily="34" charset="-120"/>
               </a:rPr>
-              <a:t>ROC-AUC: ranking quality across thresholds; 0.5 chance, 1.0 perfect — but optimistic under imbalance.</a:t>
+              <a:t>ROC-AUC: ranking quality across thresholds; 0.5 chance, 1.0 perfect: but it is optimistic under imbalance.</a:t>
             </a:r>
             <a:endParaRPr lang="en-US" sz="1500" dirty="0"/>
           </a:p>
@@ -18802,7 +19344,7 @@
                 <a:ea typeface="Calibri" pitchFamily="34" charset="-122"/>
                 <a:cs typeface="Calibri" pitchFamily="34" charset="-120"/>
               </a:rPr>
-              <a:t>A single train/validation split in a small cohort gives a noisy estimate — it depends on who landed where.</a:t>
+              <a:t>A single train/validation split in a small cohort gives a noisy estimate: it depends on who landed where.</a:t>
             </a:r>
             <a:endParaRPr lang="en-US" sz="1550" dirty="0"/>
           </a:p>
@@ -18865,7 +19407,26 @@
                 <a:ea typeface="Calibri" pitchFamily="34" charset="-122"/>
                 <a:cs typeface="Calibri" pitchFamily="34" charset="-120"/>
               </a:rPr>
-              <a:t>Still bound by Lecture 1’s rules: preprocessing and feature selection go inside each fold.</a:t>
+              <a:t>Remember: preprocessing and feature selection go inside each fold.</a:t>
+            </a:r>
+          </a:p>
+          <a:p>
+            <a:pPr marL="203200" indent="-203200">
+              <a:spcAft>
+                <a:spcPts val="1300"/>
+              </a:spcAft>
+              <a:buSzPct val="100000"/>
+              <a:buChar char="•"/>
+            </a:pPr>
+            <a:r>
+              <a:rPr lang="en-US" sz="1550" b="1" dirty="0">
+                <a:solidFill>
+                  <a:srgbClr val="0E7C86"/>
+                </a:solidFill>
+                <a:latin typeface="Calibri" pitchFamily="34" charset="0"/>
+                <a:cs typeface="Calibri" pitchFamily="34" charset="-120"/>
+              </a:rPr>
+              <a:t>Cross validation does not prevent overfitting: regularization does!</a:t>
             </a:r>
             <a:endParaRPr lang="en-US" sz="1550" dirty="0"/>
           </a:p>
@@ -20939,7 +21500,7 @@
                 <a:ea typeface="Calibri" pitchFamily="34" charset="-122"/>
                 <a:cs typeface="Calibri" pitchFamily="34" charset="-120"/>
               </a:rPr>
-              <a:t>The classic mistake: select genes on all data, then cross-validate — the CV score is already leaked.</a:t>
+              <a:t>The classic mistake: select genes on all data, then cross-validate: the CV score is already leaked.</a:t>
             </a:r>
             <a:endParaRPr lang="en-US" sz="1550" dirty="0"/>
           </a:p>
@@ -21327,7 +21888,7 @@
                 <a:ea typeface="Cambria" pitchFamily="34" charset="-122"/>
                 <a:cs typeface="Cambria" pitchFamily="34" charset="-120"/>
               </a:rPr>
-              <a:t>Overfitting — the core danger</a:t>
+              <a:t>Overfitting: the core danger</a:t>
             </a:r>
             <a:endParaRPr lang="en-US" sz="3000" dirty="0"/>
           </a:p>
@@ -21469,7 +22030,29 @@
                 <a:ea typeface="Calibri" pitchFamily="34" charset="-122"/>
                 <a:cs typeface="Calibri" pitchFamily="34" charset="-120"/>
               </a:rPr>
-              <a:t>In p ≫ n it is the default, not the exception — regularisation and honest validation are our defences.</a:t>
+              <a:t>In p ≫ n it is the default, not the exception: </a:t>
+            </a:r>
+            <a:r>
+              <a:rPr lang="en-US" sz="1600" dirty="0" err="1">
+                <a:solidFill>
+                  <a:srgbClr val="12262B"/>
+                </a:solidFill>
+                <a:latin typeface="Calibri" pitchFamily="34" charset="0"/>
+                <a:ea typeface="Calibri" pitchFamily="34" charset="-122"/>
+                <a:cs typeface="Calibri" pitchFamily="34" charset="-120"/>
+              </a:rPr>
+              <a:t>regularisation</a:t>
+            </a:r>
+            <a:r>
+              <a:rPr lang="en-US" sz="1600" dirty="0">
+                <a:solidFill>
+                  <a:srgbClr val="12262B"/>
+                </a:solidFill>
+                <a:latin typeface="Calibri" pitchFamily="34" charset="0"/>
+                <a:ea typeface="Calibri" pitchFamily="34" charset="-122"/>
+                <a:cs typeface="Calibri" pitchFamily="34" charset="-120"/>
+              </a:rPr>
+              <a:t> and honest validation are our defences.</a:t>
             </a:r>
             <a:endParaRPr lang="en-US" sz="1600" dirty="0"/>
           </a:p>
@@ -22028,7 +22611,7 @@
                 <a:ea typeface="Calibri" pitchFamily="34" charset="-122"/>
                 <a:cs typeface="Calibri" pitchFamily="34" charset="-120"/>
               </a:rPr>
-              <a:t>Coefficients rank genes by contribution — a starting point for biology.</a:t>
+              <a:t>Coefficients rank genes by contribution: a starting point for biology.</a:t>
             </a:r>
             <a:endParaRPr lang="en-US" sz="1550" dirty="0"/>
           </a:p>
@@ -24693,7 +25276,7 @@
               <a:buNone/>
             </a:pPr>
             <a:r>
-              <a:rPr lang="en-US" sz="1300" dirty="0">
+              <a:rPr lang="en-US" sz="1300" dirty="0" err="1">
                 <a:solidFill>
                   <a:srgbClr val="12262B"/>
                 </a:solidFill>
@@ -24701,7 +25284,18 @@
                 <a:ea typeface="Calibri" pitchFamily="34" charset="-122"/>
                 <a:cs typeface="Calibri" pitchFamily="34" charset="-120"/>
               </a:rPr>
-              <a:t>Recognise overfitting — the default in p ≫ n</a:t>
+              <a:t>Recognise</a:t>
+            </a:r>
+            <a:r>
+              <a:rPr lang="en-US" sz="1300" dirty="0">
+                <a:solidFill>
+                  <a:srgbClr val="12262B"/>
+                </a:solidFill>
+                <a:latin typeface="Calibri" pitchFamily="34" charset="0"/>
+                <a:ea typeface="Calibri" pitchFamily="34" charset="-122"/>
+                <a:cs typeface="Calibri" pitchFamily="34" charset="-120"/>
+              </a:rPr>
+              <a:t> overfitting: the default in p ≫ n</a:t>
             </a:r>
             <a:endParaRPr lang="en-US" sz="1300" dirty="0"/>
           </a:p>
@@ -25600,7 +26194,7 @@
                 <a:ea typeface="Calibri" pitchFamily="34" charset="-122"/>
                 <a:cs typeface="Calibri" pitchFamily="34" charset="-120"/>
               </a:rPr>
-              <a:t>The split from Lecture 1 wraps the whole thing: preprocessing and fitting are train-only.</a:t>
+              <a:t>Preprocessing and fitting must happen within train-only.</a:t>
             </a:r>
             <a:endParaRPr lang="en-US" sz="1500" dirty="0"/>
           </a:p>
@@ -25918,8 +26512,50 @@
               </a:rPr>
               <a:t>The recurring danger: a function flexible enough to memorise training patients.</a:t>
             </a:r>
+          </a:p>
+          <a:p>
+            <a:pPr marL="203200" indent="-203200">
+              <a:spcAft>
+                <a:spcPts val="1400"/>
+              </a:spcAft>
+              <a:buSzPct val="100000"/>
+              <a:buFontTx/>
+              <a:buChar char="•"/>
+            </a:pPr>
+            <a:r>
+              <a:rPr lang="en-US" sz="1600" b="1" dirty="0">
+                <a:solidFill>
+                  <a:srgbClr val="0E7C86"/>
+                </a:solidFill>
+                <a:latin typeface="Calibri" pitchFamily="34" charset="0"/>
+                <a:ea typeface="Calibri" pitchFamily="34" charset="-122"/>
+                <a:cs typeface="Calibri" pitchFamily="34" charset="-120"/>
+              </a:rPr>
+              <a:t>How to prevent overfitting: simple function, validation, </a:t>
+            </a:r>
+            <a:r>
+              <a:rPr lang="en-US" sz="1600" b="1" dirty="0" err="1">
+                <a:solidFill>
+                  <a:srgbClr val="0E7C86"/>
+                </a:solidFill>
+                <a:latin typeface="Calibri" pitchFamily="34" charset="0"/>
+                <a:ea typeface="Calibri" pitchFamily="34" charset="-122"/>
+                <a:cs typeface="Calibri" pitchFamily="34" charset="-120"/>
+              </a:rPr>
+              <a:t>regularisation</a:t>
+            </a:r>
             <a:endParaRPr lang="en-US" sz="1600" dirty="0"/>
           </a:p>
+          <a:p>
+            <a:pPr marL="203200" indent="-203200">
+              <a:spcAft>
+                <a:spcPts val="1400"/>
+              </a:spcAft>
+              <a:buSzPct val="100000"/>
+              <a:buChar char="•"/>
+            </a:pPr>
+            <a:endParaRPr lang="en-US" sz="1600" dirty="0"/>
+          </a:p>
         </p:txBody>
       </p:sp>
       <p:sp>
@@ -25930,7 +26566,7 @@
         </p:nvSpPr>
         <p:spPr>
           <a:xfrm>
-            <a:off x="6675120" y="2743200"/>
+            <a:off x="6711381" y="2204019"/>
             <a:ext cx="1554480" cy="1097280"/>
           </a:xfrm>
           <a:prstGeom prst="roundRect">
@@ -25959,7 +26595,7 @@
         </p:nvSpPr>
         <p:spPr>
           <a:xfrm>
-            <a:off x="6675120" y="2743200"/>
+            <a:off x="6711381" y="2204019"/>
             <a:ext cx="1554480" cy="1097280"/>
           </a:xfrm>
           <a:prstGeom prst="rect">
@@ -26015,7 +26651,7 @@
         </p:nvSpPr>
         <p:spPr>
           <a:xfrm>
-            <a:off x="8275320" y="3291840"/>
+            <a:off x="8311581" y="2752659"/>
             <a:ext cx="548640" cy="0"/>
           </a:xfrm>
           <a:prstGeom prst="line">
@@ -26039,7 +26675,7 @@
         </p:nvSpPr>
         <p:spPr>
           <a:xfrm>
-            <a:off x="8869680" y="2743200"/>
+            <a:off x="8905941" y="2204019"/>
             <a:ext cx="1280160" cy="1097280"/>
           </a:xfrm>
           <a:prstGeom prst="roundRect">
@@ -26068,7 +26704,7 @@
         </p:nvSpPr>
         <p:spPr>
           <a:xfrm>
-            <a:off x="8869680" y="2743200"/>
+            <a:off x="8905941" y="2204019"/>
             <a:ext cx="1280160" cy="1097280"/>
           </a:xfrm>
           <a:prstGeom prst="rect">
@@ -26107,7 +26743,7 @@
         </p:nvSpPr>
         <p:spPr>
           <a:xfrm>
-            <a:off x="10195560" y="3291840"/>
+            <a:off x="10231821" y="2752659"/>
             <a:ext cx="457200" cy="0"/>
           </a:xfrm>
           <a:prstGeom prst="line">
@@ -26131,7 +26767,7 @@
         </p:nvSpPr>
         <p:spPr>
           <a:xfrm>
-            <a:off x="10058400" y="3931920"/>
+            <a:off x="10454640" y="2507768"/>
             <a:ext cx="1737360" cy="457200"/>
           </a:xfrm>
           <a:prstGeom prst="rect">
@@ -26170,7 +26806,7 @@
         </p:nvSpPr>
         <p:spPr>
           <a:xfrm>
-            <a:off x="6675120" y="2331720"/>
+            <a:off x="6711381" y="1792539"/>
             <a:ext cx="3474720" cy="274320"/>
           </a:xfrm>
           <a:prstGeom prst="rect">
@@ -26576,7 +27212,7 @@
                 <a:ea typeface="Calibri" pitchFamily="34" charset="-122"/>
                 <a:cs typeface="Calibri" pitchFamily="34" charset="-120"/>
               </a:rPr>
-              <a:t>This binary label is a deliberate simplification of time-to-event data. It discards timing (an 11-month and a 110-month relapse look identical) and forces censoring decisions. That is fine for learning to build a baseline — we pay the debt back in Section 5 (research-grade ML) with a survival model that keeps the time axis.</a:t>
+              <a:t>This binary label is a deliberate simplification of time-to-event data. It discards timing (an 11-month and a 110-month relapse look identical) and forces censoring decisions. </a:t>
             </a:r>
             <a:endParaRPr lang="en-US" sz="1400" dirty="0"/>
           </a:p>
@@ -26808,7 +27444,7 @@
                 <a:ea typeface="Calibri" pitchFamily="34" charset="-122"/>
                 <a:cs typeface="Calibri" pitchFamily="34" charset="-120"/>
               </a:rPr>
-              <a:t>Raw expression isn’t model-ready: genes live on different scales; arrays carry technical variation.</a:t>
+              <a:t>Raw expression isn’t model-ready: genes live on different scales.</a:t>
             </a:r>
             <a:endParaRPr lang="en-US" sz="1600" dirty="0"/>
           </a:p>
@@ -26829,9 +27465,8 @@
                 <a:ea typeface="Calibri" pitchFamily="34" charset="-122"/>
                 <a:cs typeface="Calibri" pitchFamily="34" charset="-120"/>
               </a:rPr>
-              <a:t>A model can be misled by scale alone — a high-variance gene can dominate for non-biological reasons.</a:t>
-            </a:r>
-            <a:endParaRPr lang="en-US" sz="1600" dirty="0"/>
+              <a:t>A model can be misled by scale alone: a high-variance gene can dominate model optimization for no biological reason.</a:t>
+            </a:r>
           </a:p>
           <a:p>
             <a:pPr marL="203200" indent="-203200">
@@ -26850,9 +27485,8 @@
                 <a:ea typeface="Calibri" pitchFamily="34" charset="-122"/>
                 <a:cs typeface="Calibri" pitchFamily="34" charset="-120"/>
               </a:rPr>
-              <a:t>Preprocessing makes features comparable and well-behaved, without injecting outcome information.</a:t>
-            </a:r>
-            <a:endParaRPr lang="en-US" sz="1600" dirty="0"/>
+              <a:t>Different batches carry technical variation</a:t>
+            </a:r>
           </a:p>
           <a:p>
             <a:pPr marL="203200" indent="-203200">
@@ -26863,15 +27497,56 @@
               <a:buChar char="•"/>
             </a:pPr>
             <a:r>
-              <a:rPr lang="en-US" sz="1600" b="1" dirty="0">
-                <a:solidFill>
-                  <a:srgbClr val="0E7C86"/>
+              <a:rPr lang="en-US" sz="1600" dirty="0">
+                <a:solidFill>
+                  <a:srgbClr val="12262B"/>
+                </a:solidFill>
+                <a:latin typeface="Calibri" pitchFamily="34" charset="0"/>
+                <a:cs typeface="Calibri" pitchFamily="34" charset="-120"/>
+              </a:rPr>
+              <a:t>Missing values</a:t>
+            </a:r>
+            <a:endParaRPr lang="en-US" sz="1600" dirty="0"/>
+          </a:p>
+          <a:p>
+            <a:pPr marL="203200" indent="-203200">
+              <a:spcAft>
+                <a:spcPts val="1400"/>
+              </a:spcAft>
+              <a:buSzPct val="100000"/>
+              <a:buChar char="•"/>
+            </a:pPr>
+            <a:r>
+              <a:rPr lang="en-US" sz="1600" dirty="0">
+                <a:solidFill>
+                  <a:srgbClr val="12262B"/>
                 </a:solidFill>
                 <a:latin typeface="Calibri" pitchFamily="34" charset="0"/>
                 <a:ea typeface="Calibri" pitchFamily="34" charset="-122"/>
                 <a:cs typeface="Calibri" pitchFamily="34" charset="-120"/>
               </a:rPr>
-              <a:t>Golden rule (Lecture 1): every preprocessing statistic is learned on training data only.</a:t>
+              <a:t>Preprocessing makes features comparable and well-behaved, without injecting outcome information.</a:t>
+            </a:r>
+            <a:endParaRPr lang="en-US" sz="1600" dirty="0"/>
+          </a:p>
+          <a:p>
+            <a:pPr marL="203200" indent="-203200">
+              <a:spcAft>
+                <a:spcPts val="1400"/>
+              </a:spcAft>
+              <a:buSzPct val="100000"/>
+              <a:buChar char="•"/>
+            </a:pPr>
+            <a:r>
+              <a:rPr lang="en-US" sz="1600" b="1" dirty="0">
+                <a:solidFill>
+                  <a:srgbClr val="0E7C86"/>
+                </a:solidFill>
+                <a:latin typeface="Calibri" pitchFamily="34" charset="0"/>
+                <a:ea typeface="Calibri" pitchFamily="34" charset="-122"/>
+                <a:cs typeface="Calibri" pitchFamily="34" charset="-120"/>
+              </a:rPr>
+              <a:t>Every preprocessing statistic must be learned on training data only.</a:t>
             </a:r>
             <a:endParaRPr lang="en-US" sz="1600" dirty="0"/>
           </a:p>
@@ -27555,7 +28230,7 @@
                 <a:ea typeface="Cambria" pitchFamily="34" charset="-122"/>
                 <a:cs typeface="Cambria" pitchFamily="34" charset="-120"/>
               </a:rPr>
-              <a:t>Log transformation</a:t>
+              <a:t>Log transformation (or VST norm)</a:t>
             </a:r>
             <a:endParaRPr lang="en-US" sz="1500" dirty="0"/>
           </a:p>
@@ -27594,7 +28269,7 @@
                 <a:ea typeface="Calibri" pitchFamily="34" charset="-122"/>
                 <a:cs typeface="Calibri" pitchFamily="34" charset="-120"/>
               </a:rPr>
-              <a:t>Microarray intensities span orders of magnitude; log compresses the range and stabilises variance. Often already applied — check first.</a:t>
+              <a:t>Microarray intensities span orders of magnitude; log compresses the range and stabilises variance. REMEMBER: often already applied, check first.</a:t>
             </a:r>
             <a:endParaRPr lang="en-US" sz="1250" dirty="0"/>
           </a:p>
@@ -27765,7 +28440,7 @@
                 <a:ea typeface="Calibri" pitchFamily="34" charset="-122"/>
                 <a:cs typeface="Calibri" pitchFamily="34" charset="-120"/>
               </a:rPr>
-              <a:t>Centre and scale each gene so coefficients and penalties are comparable across genes.</a:t>
+              <a:t>Centre and scale each gene so coefficients and penalties are comparable across genes. WARNING: you lose relative information</a:t>
             </a:r>
             <a:endParaRPr lang="en-US" sz="1250" dirty="0"/>
           </a:p>
@@ -28404,7 +29079,26 @@
               </a:rPr>
               <a:t>A “pipeline” object enforces this for you — a habit, not an afterthought.</a:t>
             </a:r>
-            <a:endParaRPr lang="en-US" sz="1600" dirty="0"/>
+          </a:p>
+          <a:p>
+            <a:pPr marL="203200" indent="-203200">
+              <a:spcAft>
+                <a:spcPts val="1400"/>
+              </a:spcAft>
+              <a:buSzPct val="100000"/>
+              <a:buChar char="•"/>
+            </a:pPr>
+            <a:r>
+              <a:rPr lang="en-US" sz="1600" b="1" dirty="0">
+                <a:solidFill>
+                  <a:srgbClr val="0E7C86"/>
+                </a:solidFill>
+                <a:latin typeface="Calibri" pitchFamily="34" charset="0"/>
+                <a:ea typeface="Calibri" pitchFamily="34" charset="-122"/>
+                <a:cs typeface="Calibri" pitchFamily="34" charset="-120"/>
+              </a:rPr>
+              <a:t>Preprocessing steps that feels innocent, but contains data leakage: quantile normalization, filter low variance genes using all the samples!</a:t>
+            </a:r>
           </a:p>
         </p:txBody>
       </p:sp>

</xml_diff>